<commit_message>
docs(task2): embed six live screenshots into the PPTX
Captures covering the end-to-end demo path:
  01 admin dashboard (dark theme + animated stat cards + recharts)
  02 appointment booking (patient selects a priced slot)
  03 MetaMask payment signature
  04 blockchain verification page (on-chain counters resolved)
  05 audit log
  06 jsPDF prescription

Regenerated HMS_DApp_Presentation.pptx — 13 slides, 6 embedded pictures,
author metadata set to Esha Rahman.
</commit_message>
<xml_diff>
--- a/HMS_DApp_Presentation.pptx
+++ b/HMS_DApp_Presentation.pptx
@@ -22701,45 +22701,30 @@
           </a:p>
         </p:txBody>
       </p:sp>
-      <p:sp>
-        <p:nvSpPr>
-          <p:cNvPr id="6" name="TextBox 5"/>
-          <p:cNvSpPr txBox="1"/>
-          <p:nvPr/>
-        </p:nvSpPr>
-        <p:spPr>
-          <a:xfrm>
-            <a:off x="762000" y="2559050"/>
-            <a:ext cx="3429000" cy="254000"/>
-          </a:xfrm>
-          <a:prstGeom prst="rect">
-            <a:avLst/>
-          </a:prstGeom>
-          <a:noFill/>
-        </p:spPr>
-        <p:txBody>
-          <a:bodyPr wrap="square" lIns="0" rIns="0" tIns="0" bIns="0" anchor="t">
-            <a:spAutoFit/>
-          </a:bodyPr>
-          <a:lstStyle/>
-          <a:p>
-            <a:pPr algn="ctr">
-              <a:lnSpc>
-                <a:spcPct val="115000"/>
-              </a:lnSpc>
-            </a:pPr>
-            <a:r>
-              <a:rPr sz="1100" b="0" i="1">
-                <a:solidFill>
-                  <a:srgbClr val="5A6A7E"/>
-                </a:solidFill>
-                <a:latin typeface="DM Sans"/>
-              </a:rPr>
-              <a:t>[ shot-01-admin-dashboard.png ]</a:t>
-            </a:r>
-          </a:p>
-        </p:txBody>
-      </p:sp>
+      <p:pic>
+        <p:nvPicPr>
+          <p:cNvPr id="6" name="Picture 5" descr="shot-01-admin-dashboard.png"/>
+          <p:cNvPicPr>
+            <a:picLocks noChangeAspect="1"/>
+          </p:cNvPicPr>
+          <p:nvPr/>
+        </p:nvPicPr>
+        <p:blipFill>
+          <a:blip r:embed="rId2"/>
+          <a:stretch>
+            <a:fillRect/>
+          </a:stretch>
+        </p:blipFill>
+        <p:spPr>
+          <a:xfrm>
+            <a:off x="787400" y="1803400"/>
+            <a:ext cx="3378200" cy="1765300"/>
+          </a:xfrm>
+          <a:prstGeom prst="rect">
+            <a:avLst/>
+          </a:prstGeom>
+        </p:spPr>
+      </p:pic>
       <p:sp>
         <p:nvSpPr>
           <p:cNvPr id="7" name="TextBox 6"/>
@@ -22827,45 +22812,30 @@
           </a:p>
         </p:txBody>
       </p:sp>
-      <p:sp>
-        <p:nvSpPr>
-          <p:cNvPr id="9" name="TextBox 8"/>
-          <p:cNvSpPr txBox="1"/>
-          <p:nvPr/>
-        </p:nvSpPr>
-        <p:spPr>
-          <a:xfrm>
-            <a:off x="4318000" y="2559050"/>
-            <a:ext cx="3429000" cy="254000"/>
-          </a:xfrm>
-          <a:prstGeom prst="rect">
-            <a:avLst/>
-          </a:prstGeom>
-          <a:noFill/>
-        </p:spPr>
-        <p:txBody>
-          <a:bodyPr wrap="square" lIns="0" rIns="0" tIns="0" bIns="0" anchor="t">
-            <a:spAutoFit/>
-          </a:bodyPr>
-          <a:lstStyle/>
-          <a:p>
-            <a:pPr algn="ctr">
-              <a:lnSpc>
-                <a:spcPct val="115000"/>
-              </a:lnSpc>
-            </a:pPr>
-            <a:r>
-              <a:rPr sz="1100" b="0" i="1">
-                <a:solidFill>
-                  <a:srgbClr val="5A6A7E"/>
-                </a:solidFill>
-                <a:latin typeface="DM Sans"/>
-              </a:rPr>
-              <a:t>[ shot-02-appointment-booking.png ]</a:t>
-            </a:r>
-          </a:p>
-        </p:txBody>
-      </p:sp>
+      <p:pic>
+        <p:nvPicPr>
+          <p:cNvPr id="9" name="Picture 8" descr="shot-02-appointment-booking.png"/>
+          <p:cNvPicPr>
+            <a:picLocks noChangeAspect="1"/>
+          </p:cNvPicPr>
+          <p:nvPr/>
+        </p:nvPicPr>
+        <p:blipFill>
+          <a:blip r:embed="rId3"/>
+          <a:stretch>
+            <a:fillRect/>
+          </a:stretch>
+        </p:blipFill>
+        <p:spPr>
+          <a:xfrm>
+            <a:off x="4343400" y="1803400"/>
+            <a:ext cx="3378200" cy="1765300"/>
+          </a:xfrm>
+          <a:prstGeom prst="rect">
+            <a:avLst/>
+          </a:prstGeom>
+        </p:spPr>
+      </p:pic>
       <p:sp>
         <p:nvSpPr>
           <p:cNvPr id="10" name="TextBox 9"/>
@@ -22953,45 +22923,30 @@
           </a:p>
         </p:txBody>
       </p:sp>
-      <p:sp>
-        <p:nvSpPr>
-          <p:cNvPr id="12" name="TextBox 11"/>
-          <p:cNvSpPr txBox="1"/>
-          <p:nvPr/>
-        </p:nvSpPr>
-        <p:spPr>
-          <a:xfrm>
-            <a:off x="7874000" y="2559050"/>
-            <a:ext cx="3429000" cy="254000"/>
-          </a:xfrm>
-          <a:prstGeom prst="rect">
-            <a:avLst/>
-          </a:prstGeom>
-          <a:noFill/>
-        </p:spPr>
-        <p:txBody>
-          <a:bodyPr wrap="square" lIns="0" rIns="0" tIns="0" bIns="0" anchor="t">
-            <a:spAutoFit/>
-          </a:bodyPr>
-          <a:lstStyle/>
-          <a:p>
-            <a:pPr algn="ctr">
-              <a:lnSpc>
-                <a:spcPct val="115000"/>
-              </a:lnSpc>
-            </a:pPr>
-            <a:r>
-              <a:rPr sz="1100" b="0" i="1">
-                <a:solidFill>
-                  <a:srgbClr val="5A6A7E"/>
-                </a:solidFill>
-                <a:latin typeface="DM Sans"/>
-              </a:rPr>
-              <a:t>[ shot-03-metamask-payment.png ]</a:t>
-            </a:r>
-          </a:p>
-        </p:txBody>
-      </p:sp>
+      <p:pic>
+        <p:nvPicPr>
+          <p:cNvPr id="12" name="Picture 11" descr="shot-03-metamask-payment.png"/>
+          <p:cNvPicPr>
+            <a:picLocks noChangeAspect="1"/>
+          </p:cNvPicPr>
+          <p:nvPr/>
+        </p:nvPicPr>
+        <p:blipFill>
+          <a:blip r:embed="rId4"/>
+          <a:stretch>
+            <a:fillRect/>
+          </a:stretch>
+        </p:blipFill>
+        <p:spPr>
+          <a:xfrm>
+            <a:off x="7899400" y="1803400"/>
+            <a:ext cx="3378200" cy="1765300"/>
+          </a:xfrm>
+          <a:prstGeom prst="rect">
+            <a:avLst/>
+          </a:prstGeom>
+        </p:spPr>
+      </p:pic>
       <p:sp>
         <p:nvSpPr>
           <p:cNvPr id="13" name="TextBox 12"/>
@@ -23079,45 +23034,30 @@
           </a:p>
         </p:txBody>
       </p:sp>
-      <p:sp>
-        <p:nvSpPr>
-          <p:cNvPr id="15" name="TextBox 14"/>
-          <p:cNvSpPr txBox="1"/>
-          <p:nvPr/>
-        </p:nvSpPr>
-        <p:spPr>
-          <a:xfrm>
-            <a:off x="762000" y="4908550"/>
-            <a:ext cx="3429000" cy="254000"/>
-          </a:xfrm>
-          <a:prstGeom prst="rect">
-            <a:avLst/>
-          </a:prstGeom>
-          <a:noFill/>
-        </p:spPr>
-        <p:txBody>
-          <a:bodyPr wrap="square" lIns="0" rIns="0" tIns="0" bIns="0" anchor="t">
-            <a:spAutoFit/>
-          </a:bodyPr>
-          <a:lstStyle/>
-          <a:p>
-            <a:pPr algn="ctr">
-              <a:lnSpc>
-                <a:spcPct val="115000"/>
-              </a:lnSpc>
-            </a:pPr>
-            <a:r>
-              <a:rPr sz="1100" b="0" i="1">
-                <a:solidFill>
-                  <a:srgbClr val="5A6A7E"/>
-                </a:solidFill>
-                <a:latin typeface="DM Sans"/>
-              </a:rPr>
-              <a:t>[ shot-04-blockchain-verification.png ]</a:t>
-            </a:r>
-          </a:p>
-        </p:txBody>
-      </p:sp>
+      <p:pic>
+        <p:nvPicPr>
+          <p:cNvPr id="15" name="Picture 14" descr="shot-04-blockchain-verification.png"/>
+          <p:cNvPicPr>
+            <a:picLocks noChangeAspect="1"/>
+          </p:cNvPicPr>
+          <p:nvPr/>
+        </p:nvPicPr>
+        <p:blipFill>
+          <a:blip r:embed="rId5"/>
+          <a:stretch>
+            <a:fillRect/>
+          </a:stretch>
+        </p:blipFill>
+        <p:spPr>
+          <a:xfrm>
+            <a:off x="787400" y="4152900"/>
+            <a:ext cx="3378200" cy="1765300"/>
+          </a:xfrm>
+          <a:prstGeom prst="rect">
+            <a:avLst/>
+          </a:prstGeom>
+        </p:spPr>
+      </p:pic>
       <p:sp>
         <p:nvSpPr>
           <p:cNvPr id="16" name="TextBox 15"/>
@@ -23205,45 +23145,30 @@
           </a:p>
         </p:txBody>
       </p:sp>
-      <p:sp>
-        <p:nvSpPr>
-          <p:cNvPr id="18" name="TextBox 17"/>
-          <p:cNvSpPr txBox="1"/>
-          <p:nvPr/>
-        </p:nvSpPr>
-        <p:spPr>
-          <a:xfrm>
-            <a:off x="4318000" y="4908550"/>
-            <a:ext cx="3429000" cy="254000"/>
-          </a:xfrm>
-          <a:prstGeom prst="rect">
-            <a:avLst/>
-          </a:prstGeom>
-          <a:noFill/>
-        </p:spPr>
-        <p:txBody>
-          <a:bodyPr wrap="square" lIns="0" rIns="0" tIns="0" bIns="0" anchor="t">
-            <a:spAutoFit/>
-          </a:bodyPr>
-          <a:lstStyle/>
-          <a:p>
-            <a:pPr algn="ctr">
-              <a:lnSpc>
-                <a:spcPct val="115000"/>
-              </a:lnSpc>
-            </a:pPr>
-            <a:r>
-              <a:rPr sz="1100" b="0" i="1">
-                <a:solidFill>
-                  <a:srgbClr val="5A6A7E"/>
-                </a:solidFill>
-                <a:latin typeface="DM Sans"/>
-              </a:rPr>
-              <a:t>[ shot-05-audit-log.png ]</a:t>
-            </a:r>
-          </a:p>
-        </p:txBody>
-      </p:sp>
+      <p:pic>
+        <p:nvPicPr>
+          <p:cNvPr id="18" name="Picture 17" descr="shot-05-audit-log.png"/>
+          <p:cNvPicPr>
+            <a:picLocks noChangeAspect="1"/>
+          </p:cNvPicPr>
+          <p:nvPr/>
+        </p:nvPicPr>
+        <p:blipFill>
+          <a:blip r:embed="rId6"/>
+          <a:stretch>
+            <a:fillRect/>
+          </a:stretch>
+        </p:blipFill>
+        <p:spPr>
+          <a:xfrm>
+            <a:off x="4343400" y="4152900"/>
+            <a:ext cx="3378200" cy="1765300"/>
+          </a:xfrm>
+          <a:prstGeom prst="rect">
+            <a:avLst/>
+          </a:prstGeom>
+        </p:spPr>
+      </p:pic>
       <p:sp>
         <p:nvSpPr>
           <p:cNvPr id="19" name="TextBox 18"/>
@@ -23331,45 +23256,30 @@
           </a:p>
         </p:txBody>
       </p:sp>
-      <p:sp>
-        <p:nvSpPr>
-          <p:cNvPr id="21" name="TextBox 20"/>
-          <p:cNvSpPr txBox="1"/>
-          <p:nvPr/>
-        </p:nvSpPr>
-        <p:spPr>
-          <a:xfrm>
-            <a:off x="7874000" y="4908550"/>
-            <a:ext cx="3429000" cy="254000"/>
-          </a:xfrm>
-          <a:prstGeom prst="rect">
-            <a:avLst/>
-          </a:prstGeom>
-          <a:noFill/>
-        </p:spPr>
-        <p:txBody>
-          <a:bodyPr wrap="square" lIns="0" rIns="0" tIns="0" bIns="0" anchor="t">
-            <a:spAutoFit/>
-          </a:bodyPr>
-          <a:lstStyle/>
-          <a:p>
-            <a:pPr algn="ctr">
-              <a:lnSpc>
-                <a:spcPct val="115000"/>
-              </a:lnSpc>
-            </a:pPr>
-            <a:r>
-              <a:rPr sz="1100" b="0" i="1">
-                <a:solidFill>
-                  <a:srgbClr val="5A6A7E"/>
-                </a:solidFill>
-                <a:latin typeface="DM Sans"/>
-              </a:rPr>
-              <a:t>[ shot-06-prescription-pdf.png ]</a:t>
-            </a:r>
-          </a:p>
-        </p:txBody>
-      </p:sp>
+      <p:pic>
+        <p:nvPicPr>
+          <p:cNvPr id="21" name="Picture 20" descr="shot-06-prescription-pdf.png"/>
+          <p:cNvPicPr>
+            <a:picLocks noChangeAspect="1"/>
+          </p:cNvPicPr>
+          <p:nvPr/>
+        </p:nvPicPr>
+        <p:blipFill>
+          <a:blip r:embed="rId7"/>
+          <a:stretch>
+            <a:fillRect/>
+          </a:stretch>
+        </p:blipFill>
+        <p:spPr>
+          <a:xfrm>
+            <a:off x="7899400" y="4152900"/>
+            <a:ext cx="3378200" cy="1765300"/>
+          </a:xfrm>
+          <a:prstGeom prst="rect">
+            <a:avLst/>
+          </a:prstGeom>
+        </p:spPr>
+      </p:pic>
       <p:sp>
         <p:nvSpPr>
           <p:cNvPr id="22" name="TextBox 21"/>

</xml_diff>

<commit_message>
docs(task2): add 'Baseline vs Extension' slide with repo + compare URLs
Inserted a new slide 12 that shows what was inherited from the upstream
master branch (Node/Express/MongoDB backend-only CRUD) alongside what
was added on main (React SPA, Solidity HospitalRecords contract,
web3.js, MetaMask, recharts, jsPDF, audit middleware, tests, and the
Task 2 presentation bundle). Footer carries three URLs:

  - Submission (main):  github.com/rahmane001/hospital-system/tree/main
  - Baseline (master):  github.com/rahmane001/hospital-system/tree/master
  - Diff:               github.com/rahmane001/hospital-system/compare/master...main

Makes the scope of contribution explicit for the marker. Video demo and
References are renumbered to slides 13 and 14. Speaker notes, headline
count, and RecordingScript Block 9 updated accordingly.
</commit_message>
<xml_diff>
--- a/HMS_DApp_Presentation.pptx
+++ b/HMS_DApp_Presentation.pptx
@@ -18,6 +18,7 @@
     <p:sldId id="266" r:id="rId18"/>
     <p:sldId id="267" r:id="rId19"/>
     <p:sldId id="268" r:id="rId20"/>
+    <p:sldId id="269" r:id="rId21"/>
   </p:sldIdLst>
   <p:sldSz cx="12191969" cy="6858000" type="screen4x3"/>
   <p:notesSz cx="6858000" cy="9144000"/>
@@ -736,7 +737,7 @@
               <a:rPr sz="1200">
                 <a:latin typeface="Calibri"/>
               </a:rPr>
-              <a:t>This slide contains the MS Stream link to the recorded demonstration. Access has been granted to all lab tutors. The recording walks through each of the four roles, an end-to-end booking with the transaction hash appearing live in the Blockchain Verification page, a MetaMask-signed payment, and the audit log.</a:t>
+              <a:t>This slide makes the scope of my contribution explicit for the marker. The master branch is the pristine upstream baseline — a backend-only Node, Express, and MongoDB CRUD application with no blockchain, no React frontend, and no role-aware UI. The main branch is the submission: I layered a React 19 single-page app, a Solidity smart contract deployed to Ganache, web3.js integration, MetaMask payments, recharts analytics, jsPDF exports, audit middleware, notifications, and the entire Task 2 presentation bundle on top. The two branches live on the same GitHub repo so the tutor can diff them directly using the compare URL at the bottom of the slide. 112 files changed, roughly 59-thousand lines added.</a:t>
             </a:r>
           </a:p>
         </p:txBody>
@@ -762,6 +763,79 @@
 </file>
 
 <file path=ppt/notesSlides/notesSlide13.xml><?xml version="1.0" encoding="utf-8"?>
+<p:notes xmlns:a="http://schemas.openxmlformats.org/drawingml/2006/main" xmlns:p="http://schemas.openxmlformats.org/presentationml/2006/main" xmlns:r="http://schemas.openxmlformats.org/officeDocument/2006/relationships">
+  <p:cSld>
+    <p:spTree>
+      <p:nvGrpSpPr>
+        <p:cNvPr id="1" name=""/>
+        <p:cNvGrpSpPr/>
+        <p:nvPr/>
+      </p:nvGrpSpPr>
+      <p:grpSpPr>
+        <a:xfrm>
+          <a:off x="0" y="0"/>
+          <a:ext cx="0" cy="0"/>
+          <a:chOff x="0" y="0"/>
+          <a:chExt cx="0" cy="0"/>
+        </a:xfrm>
+      </p:grpSpPr>
+      <p:sp>
+        <p:nvSpPr>
+          <p:cNvPr id="2" name="Slide Image Placeholder 1"/>
+          <p:cNvSpPr>
+            <a:spLocks noGrp="1"/>
+          </p:cNvSpPr>
+          <p:nvPr>
+            <p:ph type="sldImg" idx="2"/>
+          </p:nvPr>
+        </p:nvSpPr>
+        <p:spPr/>
+      </p:sp>
+      <p:sp>
+        <p:nvSpPr>
+          <p:cNvPr id="3" name="Notes Placeholder 2"/>
+          <p:cNvSpPr>
+            <a:spLocks noGrp="1"/>
+          </p:cNvSpPr>
+          <p:nvPr>
+            <p:ph type="body" idx="3" sz="quarter"/>
+          </p:nvPr>
+        </p:nvSpPr>
+        <p:spPr/>
+        <p:txBody>
+          <a:bodyPr/>
+          <a:lstStyle/>
+          <a:p>
+            <a:r>
+              <a:rPr sz="1200">
+                <a:latin typeface="Calibri"/>
+              </a:rPr>
+              <a:t>This slide contains the MS Stream link to the recorded demonstration. Access has been granted to all lab tutors. The recording walks through each of the four roles, an end-to-end booking with the transaction hash appearing live in the Blockchain Verification page, a MetaMask-signed payment, and the audit log.</a:t>
+            </a:r>
+          </a:p>
+        </p:txBody>
+      </p:sp>
+      <p:sp>
+        <p:nvSpPr>
+          <p:cNvPr id="4" name="Slide Number Placeholder 3"/>
+          <p:cNvSpPr>
+            <a:spLocks noGrp="1"/>
+          </p:cNvSpPr>
+          <p:nvPr>
+            <p:ph type="sldNum" idx="5" sz="quarter"/>
+          </p:nvPr>
+        </p:nvSpPr>
+        <p:spPr/>
+      </p:sp>
+    </p:spTree>
+  </p:cSld>
+  <p:clrMapOvr>
+    <a:masterClrMapping/>
+  </p:clrMapOvr>
+</p:notes>
+</file>
+
+<file path=ppt/notesSlides/notesSlide14.xml><?xml version="1.0" encoding="utf-8"?>
 <p:notes xmlns:a="http://schemas.openxmlformats.org/drawingml/2006/main" xmlns:p="http://schemas.openxmlformats.org/presentationml/2006/main" xmlns:r="http://schemas.openxmlformats.org/officeDocument/2006/relationships">
   <p:cSld>
     <p:spTree>
@@ -7324,7 +7398,7 @@
             <a:avLst/>
           </a:prstGeom>
           <a:solidFill>
-            <a:srgbClr val="0D1B2A"/>
+            <a:srgbClr val="F9FAFB"/>
           </a:solidFill>
           <a:ln>
             <a:noFill/>
@@ -7361,21 +7435,21 @@
         </p:nvSpPr>
         <p:spPr>
           <a:xfrm>
-            <a:off x="0" y="1651000"/>
-            <a:ext cx="12191969" cy="215900"/>
-          </a:xfrm>
-          <a:prstGeom prst="rect">
-            <a:avLst/>
-          </a:prstGeom>
-          <a:noFill/>
-        </p:spPr>
-        <p:txBody>
-          <a:bodyPr wrap="square" lIns="0" rIns="0" tIns="0" bIns="0" anchor="t">
-            <a:spAutoFit/>
-          </a:bodyPr>
-          <a:lstStyle/>
-          <a:p>
-            <a:pPr algn="ctr">
+            <a:off x="762000" y="635000"/>
+            <a:ext cx="6350000" cy="215900"/>
+          </a:xfrm>
+          <a:prstGeom prst="rect">
+            <a:avLst/>
+          </a:prstGeom>
+          <a:noFill/>
+        </p:spPr>
+        <p:txBody>
+          <a:bodyPr wrap="square" lIns="0" rIns="0" tIns="0" bIns="0" anchor="t">
+            <a:spAutoFit/>
+          </a:bodyPr>
+          <a:lstStyle/>
+          <a:p>
+            <a:pPr algn="l">
               <a:lnSpc>
                 <a:spcPct val="115000"/>
               </a:lnSpc>
@@ -7383,11 +7457,11 @@
             <a:r>
               <a:rPr sz="1200" b="1" i="0" spc="240">
                 <a:solidFill>
-                  <a:srgbClr val="6CB8DA"/>
-                </a:solidFill>
-                <a:latin typeface="DM Sans"/>
-              </a:rPr>
-              <a:t>11 — DEMONSTRATION</a:t>
+                  <a:srgbClr val="1A8FC2"/>
+                </a:solidFill>
+                <a:latin typeface="DM Sans"/>
+              </a:rPr>
+              <a:t>11 — SCOPE OF CONTRIBUTION</a:t>
             </a:r>
           </a:p>
         </p:txBody>
@@ -7400,60 +7474,56 @@
         </p:nvSpPr>
         <p:spPr>
           <a:xfrm>
-            <a:off x="0" y="2095500"/>
-            <a:ext cx="12191969" cy="762000"/>
-          </a:xfrm>
-          <a:prstGeom prst="rect">
-            <a:avLst/>
-          </a:prstGeom>
-          <a:noFill/>
-        </p:spPr>
-        <p:txBody>
-          <a:bodyPr wrap="square" lIns="0" rIns="0" tIns="0" bIns="0" anchor="t">
-            <a:spAutoFit/>
-          </a:bodyPr>
-          <a:lstStyle/>
-          <a:p>
-            <a:pPr algn="ctr">
-              <a:lnSpc>
-                <a:spcPct val="115000"/>
-              </a:lnSpc>
-            </a:pPr>
-            <a:r>
-              <a:rPr sz="4000" b="1" i="0">
-                <a:solidFill>
-                  <a:srgbClr val="F9FAFB"/>
-                </a:solidFill>
-                <a:latin typeface="DM Sans"/>
-              </a:rPr>
-              <a:t>Video Demonstration</a:t>
-            </a:r>
-          </a:p>
-        </p:txBody>
-      </p:sp>
-      <p:sp>
-        <p:nvSpPr>
-          <p:cNvPr id="5" name="Rounded Rectangle 4"/>
+            <a:off x="762000" y="850900"/>
+            <a:ext cx="10668000" cy="571500"/>
+          </a:xfrm>
+          <a:prstGeom prst="rect">
+            <a:avLst/>
+          </a:prstGeom>
+          <a:noFill/>
+        </p:spPr>
+        <p:txBody>
+          <a:bodyPr wrap="square" lIns="0" rIns="0" tIns="0" bIns="0" anchor="t">
+            <a:spAutoFit/>
+          </a:bodyPr>
+          <a:lstStyle/>
+          <a:p>
+            <a:pPr algn="l">
+              <a:lnSpc>
+                <a:spcPct val="105000"/>
+              </a:lnSpc>
+            </a:pPr>
+            <a:r>
+              <a:rPr sz="3600" b="1" i="0">
+                <a:solidFill>
+                  <a:srgbClr val="0D1B2A"/>
+                </a:solidFill>
+                <a:latin typeface="DM Sans"/>
+              </a:rPr>
+              <a:t>Baseline vs Extension</a:t>
+            </a:r>
+          </a:p>
+        </p:txBody>
+      </p:sp>
+      <p:sp>
+        <p:nvSpPr>
+          <p:cNvPr id="5" name="Rectangle 4"/>
           <p:cNvSpPr/>
           <p:nvPr/>
         </p:nvSpPr>
         <p:spPr>
           <a:xfrm>
-            <a:off x="2285984" y="3365500"/>
-            <a:ext cx="7620000" cy="1397000"/>
-          </a:xfrm>
-          <a:prstGeom prst="roundRect">
-            <a:avLst>
-              <a:gd name="adj" fmla="val 8000"/>
-            </a:avLst>
+            <a:off x="762000" y="1778000"/>
+            <a:ext cx="5207000" cy="50800"/>
+          </a:xfrm>
+          <a:prstGeom prst="rect">
+            <a:avLst/>
           </a:prstGeom>
           <a:solidFill>
-            <a:srgbClr val="182A42"/>
+            <a:srgbClr val="5A6A7E"/>
           </a:solidFill>
-          <a:ln w="25400">
-            <a:solidFill>
-              <a:srgbClr val="244A70"/>
-            </a:solidFill>
+          <a:ln>
+            <a:noFill/>
           </a:ln>
           <a:effectLst/>
         </p:spPr>
@@ -7481,133 +7551,1290 @@
       </p:sp>
       <p:sp>
         <p:nvSpPr>
-          <p:cNvPr id="6" name="TextBox 5"/>
-          <p:cNvSpPr txBox="1"/>
-          <p:nvPr/>
-        </p:nvSpPr>
-        <p:spPr>
-          <a:xfrm>
-            <a:off x="2285984" y="3619500"/>
-            <a:ext cx="7620000" cy="228600"/>
-          </a:xfrm>
-          <a:prstGeom prst="rect">
-            <a:avLst/>
-          </a:prstGeom>
-          <a:noFill/>
-        </p:spPr>
-        <p:txBody>
-          <a:bodyPr wrap="square" lIns="0" rIns="0" tIns="0" bIns="0" anchor="t">
-            <a:spAutoFit/>
-          </a:bodyPr>
-          <a:lstStyle/>
-          <a:p>
-            <a:pPr algn="ctr">
+          <p:cNvPr id="6" name="Rounded Rectangle 5"/>
+          <p:cNvSpPr/>
+          <p:nvPr/>
+        </p:nvSpPr>
+        <p:spPr>
+          <a:xfrm>
+            <a:off x="762000" y="1828800"/>
+            <a:ext cx="5207000" cy="3556000"/>
+          </a:xfrm>
+          <a:prstGeom prst="roundRect">
+            <a:avLst>
+              <a:gd name="adj" fmla="val 3000"/>
+            </a:avLst>
+          </a:prstGeom>
+          <a:solidFill>
+            <a:srgbClr val="FAF3E6"/>
+          </a:solidFill>
+          <a:ln>
+            <a:noFill/>
+          </a:ln>
+          <a:effectLst/>
+        </p:spPr>
+        <p:style>
+          <a:lnRef idx="1">
+            <a:schemeClr val="accent1"/>
+          </a:lnRef>
+          <a:fillRef idx="3">
+            <a:schemeClr val="accent1"/>
+          </a:fillRef>
+          <a:effectRef idx="2">
+            <a:schemeClr val="accent1"/>
+          </a:effectRef>
+          <a:fontRef idx="minor">
+            <a:schemeClr val="lt1"/>
+          </a:fontRef>
+        </p:style>
+        <p:txBody>
+          <a:bodyPr rtlCol="0" anchor="ctr"/>
+          <a:lstStyle/>
+          <a:p>
+            <a:pPr algn="ctr"/>
+          </a:p>
+        </p:txBody>
+      </p:sp>
+      <p:sp>
+        <p:nvSpPr>
+          <p:cNvPr id="7" name="TextBox 6"/>
+          <p:cNvSpPr txBox="1"/>
+          <p:nvPr/>
+        </p:nvSpPr>
+        <p:spPr>
+          <a:xfrm>
+            <a:off x="952500" y="1968500"/>
+            <a:ext cx="4826000" cy="279400"/>
+          </a:xfrm>
+          <a:prstGeom prst="rect">
+            <a:avLst/>
+          </a:prstGeom>
+          <a:noFill/>
+        </p:spPr>
+        <p:txBody>
+          <a:bodyPr wrap="square" lIns="0" rIns="0" tIns="0" bIns="0" anchor="t">
+            <a:spAutoFit/>
+          </a:bodyPr>
+          <a:lstStyle/>
+          <a:p>
+            <a:pPr algn="l">
               <a:lnSpc>
                 <a:spcPct val="115000"/>
               </a:lnSpc>
             </a:pPr>
             <a:r>
-              <a:rPr sz="1200" b="1" i="0" spc="200">
-                <a:solidFill>
-                  <a:srgbClr val="8A94A2"/>
-                </a:solidFill>
-                <a:latin typeface="DM Sans"/>
-              </a:rPr>
-              <a:t>MS STREAM RECORDING</a:t>
-            </a:r>
-          </a:p>
-        </p:txBody>
-      </p:sp>
-      <p:sp>
-        <p:nvSpPr>
-          <p:cNvPr id="7" name="TextBox 6"/>
-          <p:cNvSpPr txBox="1"/>
-          <p:nvPr/>
-        </p:nvSpPr>
-        <p:spPr>
-          <a:xfrm>
-            <a:off x="2539984" y="4000500"/>
-            <a:ext cx="7112000" cy="508000"/>
-          </a:xfrm>
-          <a:prstGeom prst="rect">
-            <a:avLst/>
-          </a:prstGeom>
-          <a:noFill/>
-        </p:spPr>
-        <p:txBody>
-          <a:bodyPr wrap="square" lIns="0" rIns="0" tIns="0" bIns="0" anchor="t">
-            <a:spAutoFit/>
-          </a:bodyPr>
-          <a:lstStyle/>
-          <a:p>
-            <a:pPr algn="ctr">
+              <a:rPr sz="1300" b="1" i="0" spc="200">
+                <a:solidFill>
+                  <a:srgbClr val="5A6A7E"/>
+                </a:solidFill>
+                <a:latin typeface="DM Sans"/>
+              </a:rPr>
+              <a:t>MASTER BRANCH — BASELINE</a:t>
+            </a:r>
+          </a:p>
+        </p:txBody>
+      </p:sp>
+      <p:sp>
+        <p:nvSpPr>
+          <p:cNvPr id="8" name="TextBox 7"/>
+          <p:cNvSpPr txBox="1"/>
+          <p:nvPr/>
+        </p:nvSpPr>
+        <p:spPr>
+          <a:xfrm>
+            <a:off x="952500" y="2349500"/>
+            <a:ext cx="4826000" cy="203200"/>
+          </a:xfrm>
+          <a:prstGeom prst="rect">
+            <a:avLst/>
+          </a:prstGeom>
+          <a:noFill/>
+        </p:spPr>
+        <p:txBody>
+          <a:bodyPr wrap="square" lIns="0" rIns="0" tIns="0" bIns="0" anchor="t">
+            <a:spAutoFit/>
+          </a:bodyPr>
+          <a:lstStyle/>
+          <a:p>
+            <a:pPr algn="l">
               <a:lnSpc>
                 <a:spcPct val="115000"/>
               </a:lnSpc>
             </a:pPr>
             <a:r>
-              <a:rPr sz="1600" b="0" i="0">
-                <a:solidFill>
-                  <a:srgbClr val="6CB8DA"/>
+              <a:rPr sz="1100" b="1" i="0">
+                <a:solidFill>
+                  <a:srgbClr val="0D1B2A"/>
+                </a:solidFill>
+                <a:latin typeface="DM Sans"/>
+              </a:rPr>
+              <a:t>Node.js + Express API</a:t>
+            </a:r>
+          </a:p>
+        </p:txBody>
+      </p:sp>
+      <p:sp>
+        <p:nvSpPr>
+          <p:cNvPr id="9" name="TextBox 8"/>
+          <p:cNvSpPr txBox="1"/>
+          <p:nvPr/>
+        </p:nvSpPr>
+        <p:spPr>
+          <a:xfrm>
+            <a:off x="952500" y="2565400"/>
+            <a:ext cx="4826000" cy="317500"/>
+          </a:xfrm>
+          <a:prstGeom prst="rect">
+            <a:avLst/>
+          </a:prstGeom>
+          <a:noFill/>
+        </p:spPr>
+        <p:txBody>
+          <a:bodyPr wrap="square" lIns="0" rIns="0" tIns="0" bIns="0" anchor="t">
+            <a:spAutoFit/>
+          </a:bodyPr>
+          <a:lstStyle/>
+          <a:p>
+            <a:pPr algn="l">
+              <a:lnSpc>
+                <a:spcPct val="130000"/>
+              </a:lnSpc>
+            </a:pPr>
+            <a:r>
+              <a:rPr sz="900" b="0" i="0">
+                <a:solidFill>
+                  <a:srgbClr val="5A6A7E"/>
+                </a:solidFill>
+                <a:latin typeface="DM Sans"/>
+              </a:rPr>
+              <a:t>Auth, appointments, bills — REST only.</a:t>
+            </a:r>
+          </a:p>
+        </p:txBody>
+      </p:sp>
+      <p:sp>
+        <p:nvSpPr>
+          <p:cNvPr id="10" name="TextBox 9"/>
+          <p:cNvSpPr txBox="1"/>
+          <p:nvPr/>
+        </p:nvSpPr>
+        <p:spPr>
+          <a:xfrm>
+            <a:off x="952500" y="2857500"/>
+            <a:ext cx="4826000" cy="203200"/>
+          </a:xfrm>
+          <a:prstGeom prst="rect">
+            <a:avLst/>
+          </a:prstGeom>
+          <a:noFill/>
+        </p:spPr>
+        <p:txBody>
+          <a:bodyPr wrap="square" lIns="0" rIns="0" tIns="0" bIns="0" anchor="t">
+            <a:spAutoFit/>
+          </a:bodyPr>
+          <a:lstStyle/>
+          <a:p>
+            <a:pPr algn="l">
+              <a:lnSpc>
+                <a:spcPct val="115000"/>
+              </a:lnSpc>
+            </a:pPr>
+            <a:r>
+              <a:rPr sz="1100" b="1" i="0">
+                <a:solidFill>
+                  <a:srgbClr val="0D1B2A"/>
+                </a:solidFill>
+                <a:latin typeface="DM Sans"/>
+              </a:rPr>
+              <a:t>MongoDB + Mongoose</a:t>
+            </a:r>
+          </a:p>
+        </p:txBody>
+      </p:sp>
+      <p:sp>
+        <p:nvSpPr>
+          <p:cNvPr id="11" name="TextBox 10"/>
+          <p:cNvSpPr txBox="1"/>
+          <p:nvPr/>
+        </p:nvSpPr>
+        <p:spPr>
+          <a:xfrm>
+            <a:off x="952500" y="3073400"/>
+            <a:ext cx="4826000" cy="317500"/>
+          </a:xfrm>
+          <a:prstGeom prst="rect">
+            <a:avLst/>
+          </a:prstGeom>
+          <a:noFill/>
+        </p:spPr>
+        <p:txBody>
+          <a:bodyPr wrap="square" lIns="0" rIns="0" tIns="0" bIns="0" anchor="t">
+            <a:spAutoFit/>
+          </a:bodyPr>
+          <a:lstStyle/>
+          <a:p>
+            <a:pPr algn="l">
+              <a:lnSpc>
+                <a:spcPct val="130000"/>
+              </a:lnSpc>
+            </a:pPr>
+            <a:r>
+              <a:rPr sz="900" b="0" i="0">
+                <a:solidFill>
+                  <a:srgbClr val="5A6A7E"/>
+                </a:solidFill>
+                <a:latin typeface="DM Sans"/>
+              </a:rPr>
+              <a:t>Schemas for User, Appointment, Bill, Prescription.</a:t>
+            </a:r>
+          </a:p>
+        </p:txBody>
+      </p:sp>
+      <p:sp>
+        <p:nvSpPr>
+          <p:cNvPr id="12" name="TextBox 11"/>
+          <p:cNvSpPr txBox="1"/>
+          <p:nvPr/>
+        </p:nvSpPr>
+        <p:spPr>
+          <a:xfrm>
+            <a:off x="952500" y="3365500"/>
+            <a:ext cx="4826000" cy="203200"/>
+          </a:xfrm>
+          <a:prstGeom prst="rect">
+            <a:avLst/>
+          </a:prstGeom>
+          <a:noFill/>
+        </p:spPr>
+        <p:txBody>
+          <a:bodyPr wrap="square" lIns="0" rIns="0" tIns="0" bIns="0" anchor="t">
+            <a:spAutoFit/>
+          </a:bodyPr>
+          <a:lstStyle/>
+          <a:p>
+            <a:pPr algn="l">
+              <a:lnSpc>
+                <a:spcPct val="115000"/>
+              </a:lnSpc>
+            </a:pPr>
+            <a:r>
+              <a:rPr sz="1100" b="1" i="0">
+                <a:solidFill>
+                  <a:srgbClr val="0D1B2A"/>
+                </a:solidFill>
+                <a:latin typeface="DM Sans"/>
+              </a:rPr>
+              <a:t>JWT + bcrypt auth</a:t>
+            </a:r>
+          </a:p>
+        </p:txBody>
+      </p:sp>
+      <p:sp>
+        <p:nvSpPr>
+          <p:cNvPr id="13" name="TextBox 12"/>
+          <p:cNvSpPr txBox="1"/>
+          <p:nvPr/>
+        </p:nvSpPr>
+        <p:spPr>
+          <a:xfrm>
+            <a:off x="952500" y="3581400"/>
+            <a:ext cx="4826000" cy="317500"/>
+          </a:xfrm>
+          <a:prstGeom prst="rect">
+            <a:avLst/>
+          </a:prstGeom>
+          <a:noFill/>
+        </p:spPr>
+        <p:txBody>
+          <a:bodyPr wrap="square" lIns="0" rIns="0" tIns="0" bIns="0" anchor="t">
+            <a:spAutoFit/>
+          </a:bodyPr>
+          <a:lstStyle/>
+          <a:p>
+            <a:pPr algn="l">
+              <a:lnSpc>
+                <a:spcPct val="130000"/>
+              </a:lnSpc>
+            </a:pPr>
+            <a:r>
+              <a:rPr sz="900" b="0" i="0">
+                <a:solidFill>
+                  <a:srgbClr val="5A6A7E"/>
+                </a:solidFill>
+                <a:latin typeface="DM Sans"/>
+              </a:rPr>
+              <a:t>Role-agnostic, no doctor-approval flow.</a:t>
+            </a:r>
+          </a:p>
+        </p:txBody>
+      </p:sp>
+      <p:sp>
+        <p:nvSpPr>
+          <p:cNvPr id="14" name="TextBox 13"/>
+          <p:cNvSpPr txBox="1"/>
+          <p:nvPr/>
+        </p:nvSpPr>
+        <p:spPr>
+          <a:xfrm>
+            <a:off x="952500" y="3873500"/>
+            <a:ext cx="4826000" cy="203200"/>
+          </a:xfrm>
+          <a:prstGeom prst="rect">
+            <a:avLst/>
+          </a:prstGeom>
+          <a:noFill/>
+        </p:spPr>
+        <p:txBody>
+          <a:bodyPr wrap="square" lIns="0" rIns="0" tIns="0" bIns="0" anchor="t">
+            <a:spAutoFit/>
+          </a:bodyPr>
+          <a:lstStyle/>
+          <a:p>
+            <a:pPr algn="l">
+              <a:lnSpc>
+                <a:spcPct val="115000"/>
+              </a:lnSpc>
+            </a:pPr>
+            <a:r>
+              <a:rPr sz="1100" b="1" i="0">
+                <a:solidFill>
+                  <a:srgbClr val="0D1B2A"/>
+                </a:solidFill>
+                <a:latin typeface="DM Sans"/>
+              </a:rPr>
+              <a:t>Swagger docs + seed script</a:t>
+            </a:r>
+          </a:p>
+        </p:txBody>
+      </p:sp>
+      <p:sp>
+        <p:nvSpPr>
+          <p:cNvPr id="15" name="TextBox 14"/>
+          <p:cNvSpPr txBox="1"/>
+          <p:nvPr/>
+        </p:nvSpPr>
+        <p:spPr>
+          <a:xfrm>
+            <a:off x="952500" y="4089400"/>
+            <a:ext cx="4826000" cy="317500"/>
+          </a:xfrm>
+          <a:prstGeom prst="rect">
+            <a:avLst/>
+          </a:prstGeom>
+          <a:noFill/>
+        </p:spPr>
+        <p:txBody>
+          <a:bodyPr wrap="square" lIns="0" rIns="0" tIns="0" bIns="0" anchor="t">
+            <a:spAutoFit/>
+          </a:bodyPr>
+          <a:lstStyle/>
+          <a:p>
+            <a:pPr algn="l">
+              <a:lnSpc>
+                <a:spcPct val="130000"/>
+              </a:lnSpc>
+            </a:pPr>
+            <a:r>
+              <a:rPr sz="900" b="0" i="0">
+                <a:solidFill>
+                  <a:srgbClr val="5A6A7E"/>
+                </a:solidFill>
+                <a:latin typeface="DM Sans"/>
+              </a:rPr>
+              <a:t>Basic Postman-style API surface.</a:t>
+            </a:r>
+          </a:p>
+        </p:txBody>
+      </p:sp>
+      <p:sp>
+        <p:nvSpPr>
+          <p:cNvPr id="16" name="TextBox 15"/>
+          <p:cNvSpPr txBox="1"/>
+          <p:nvPr/>
+        </p:nvSpPr>
+        <p:spPr>
+          <a:xfrm>
+            <a:off x="952500" y="4381500"/>
+            <a:ext cx="4826000" cy="203200"/>
+          </a:xfrm>
+          <a:prstGeom prst="rect">
+            <a:avLst/>
+          </a:prstGeom>
+          <a:noFill/>
+        </p:spPr>
+        <p:txBody>
+          <a:bodyPr wrap="square" lIns="0" rIns="0" tIns="0" bIns="0" anchor="t">
+            <a:spAutoFit/>
+          </a:bodyPr>
+          <a:lstStyle/>
+          <a:p>
+            <a:pPr algn="l">
+              <a:lnSpc>
+                <a:spcPct val="115000"/>
+              </a:lnSpc>
+            </a:pPr>
+            <a:r>
+              <a:rPr sz="1100" b="1" i="0">
+                <a:solidFill>
+                  <a:srgbClr val="0D1B2A"/>
+                </a:solidFill>
+                <a:latin typeface="DM Sans"/>
+              </a:rPr>
+              <a:t>No frontend</a:t>
+            </a:r>
+          </a:p>
+        </p:txBody>
+      </p:sp>
+      <p:sp>
+        <p:nvSpPr>
+          <p:cNvPr id="17" name="TextBox 16"/>
+          <p:cNvSpPr txBox="1"/>
+          <p:nvPr/>
+        </p:nvSpPr>
+        <p:spPr>
+          <a:xfrm>
+            <a:off x="952500" y="4597400"/>
+            <a:ext cx="4826000" cy="317500"/>
+          </a:xfrm>
+          <a:prstGeom prst="rect">
+            <a:avLst/>
+          </a:prstGeom>
+          <a:noFill/>
+        </p:spPr>
+        <p:txBody>
+          <a:bodyPr wrap="square" lIns="0" rIns="0" tIns="0" bIns="0" anchor="t">
+            <a:spAutoFit/>
+          </a:bodyPr>
+          <a:lstStyle/>
+          <a:p>
+            <a:pPr algn="l">
+              <a:lnSpc>
+                <a:spcPct val="130000"/>
+              </a:lnSpc>
+            </a:pPr>
+            <a:r>
+              <a:rPr sz="900" b="0" i="0">
+                <a:solidFill>
+                  <a:srgbClr val="5A6A7E"/>
+                </a:solidFill>
+                <a:latin typeface="DM Sans"/>
+              </a:rPr>
+              <a:t>Backend-only — no UI, no dashboards.</a:t>
+            </a:r>
+          </a:p>
+        </p:txBody>
+      </p:sp>
+      <p:sp>
+        <p:nvSpPr>
+          <p:cNvPr id="18" name="TextBox 17"/>
+          <p:cNvSpPr txBox="1"/>
+          <p:nvPr/>
+        </p:nvSpPr>
+        <p:spPr>
+          <a:xfrm>
+            <a:off x="952500" y="4889500"/>
+            <a:ext cx="4826000" cy="203200"/>
+          </a:xfrm>
+          <a:prstGeom prst="rect">
+            <a:avLst/>
+          </a:prstGeom>
+          <a:noFill/>
+        </p:spPr>
+        <p:txBody>
+          <a:bodyPr wrap="square" lIns="0" rIns="0" tIns="0" bIns="0" anchor="t">
+            <a:spAutoFit/>
+          </a:bodyPr>
+          <a:lstStyle/>
+          <a:p>
+            <a:pPr algn="l">
+              <a:lnSpc>
+                <a:spcPct val="115000"/>
+              </a:lnSpc>
+            </a:pPr>
+            <a:r>
+              <a:rPr sz="1100" b="1" i="0">
+                <a:solidFill>
+                  <a:srgbClr val="0D1B2A"/>
+                </a:solidFill>
+                <a:latin typeface="DM Sans"/>
+              </a:rPr>
+              <a:t>No blockchain</a:t>
+            </a:r>
+          </a:p>
+        </p:txBody>
+      </p:sp>
+      <p:sp>
+        <p:nvSpPr>
+          <p:cNvPr id="19" name="TextBox 18"/>
+          <p:cNvSpPr txBox="1"/>
+          <p:nvPr/>
+        </p:nvSpPr>
+        <p:spPr>
+          <a:xfrm>
+            <a:off x="952500" y="5105400"/>
+            <a:ext cx="4826000" cy="317500"/>
+          </a:xfrm>
+          <a:prstGeom prst="rect">
+            <a:avLst/>
+          </a:prstGeom>
+          <a:noFill/>
+        </p:spPr>
+        <p:txBody>
+          <a:bodyPr wrap="square" lIns="0" rIns="0" tIns="0" bIns="0" anchor="t">
+            <a:spAutoFit/>
+          </a:bodyPr>
+          <a:lstStyle/>
+          <a:p>
+            <a:pPr algn="l">
+              <a:lnSpc>
+                <a:spcPct val="130000"/>
+              </a:lnSpc>
+            </a:pPr>
+            <a:r>
+              <a:rPr sz="900" b="0" i="0">
+                <a:solidFill>
+                  <a:srgbClr val="5A6A7E"/>
+                </a:solidFill>
+                <a:latin typeface="DM Sans"/>
+              </a:rPr>
+              <a:t>All trust on the API layer.</a:t>
+            </a:r>
+          </a:p>
+        </p:txBody>
+      </p:sp>
+      <p:sp>
+        <p:nvSpPr>
+          <p:cNvPr id="20" name="Rectangle 19"/>
+          <p:cNvSpPr/>
+          <p:nvPr/>
+        </p:nvSpPr>
+        <p:spPr>
+          <a:xfrm>
+            <a:off x="6223000" y="1778000"/>
+            <a:ext cx="5207000" cy="50800"/>
+          </a:xfrm>
+          <a:prstGeom prst="rect">
+            <a:avLst/>
+          </a:prstGeom>
+          <a:solidFill>
+            <a:srgbClr val="1A8FC2"/>
+          </a:solidFill>
+          <a:ln>
+            <a:noFill/>
+          </a:ln>
+          <a:effectLst/>
+        </p:spPr>
+        <p:style>
+          <a:lnRef idx="1">
+            <a:schemeClr val="accent1"/>
+          </a:lnRef>
+          <a:fillRef idx="3">
+            <a:schemeClr val="accent1"/>
+          </a:fillRef>
+          <a:effectRef idx="2">
+            <a:schemeClr val="accent1"/>
+          </a:effectRef>
+          <a:fontRef idx="minor">
+            <a:schemeClr val="lt1"/>
+          </a:fontRef>
+        </p:style>
+        <p:txBody>
+          <a:bodyPr rtlCol="0" anchor="ctr"/>
+          <a:lstStyle/>
+          <a:p>
+            <a:pPr algn="ctr"/>
+          </a:p>
+        </p:txBody>
+      </p:sp>
+      <p:sp>
+        <p:nvSpPr>
+          <p:cNvPr id="21" name="Rounded Rectangle 20"/>
+          <p:cNvSpPr/>
+          <p:nvPr/>
+        </p:nvSpPr>
+        <p:spPr>
+          <a:xfrm>
+            <a:off x="6223000" y="1828800"/>
+            <a:ext cx="5207000" cy="3556000"/>
+          </a:xfrm>
+          <a:prstGeom prst="roundRect">
+            <a:avLst>
+              <a:gd name="adj" fmla="val 3000"/>
+            </a:avLst>
+          </a:prstGeom>
+          <a:solidFill>
+            <a:srgbClr val="EAF5FC"/>
+          </a:solidFill>
+          <a:ln>
+            <a:noFill/>
+          </a:ln>
+          <a:effectLst/>
+        </p:spPr>
+        <p:style>
+          <a:lnRef idx="1">
+            <a:schemeClr val="accent1"/>
+          </a:lnRef>
+          <a:fillRef idx="3">
+            <a:schemeClr val="accent1"/>
+          </a:fillRef>
+          <a:effectRef idx="2">
+            <a:schemeClr val="accent1"/>
+          </a:effectRef>
+          <a:fontRef idx="minor">
+            <a:schemeClr val="lt1"/>
+          </a:fontRef>
+        </p:style>
+        <p:txBody>
+          <a:bodyPr rtlCol="0" anchor="ctr"/>
+          <a:lstStyle/>
+          <a:p>
+            <a:pPr algn="ctr"/>
+          </a:p>
+        </p:txBody>
+      </p:sp>
+      <p:sp>
+        <p:nvSpPr>
+          <p:cNvPr id="22" name="TextBox 21"/>
+          <p:cNvSpPr txBox="1"/>
+          <p:nvPr/>
+        </p:nvSpPr>
+        <p:spPr>
+          <a:xfrm>
+            <a:off x="6413500" y="1968500"/>
+            <a:ext cx="4826000" cy="279400"/>
+          </a:xfrm>
+          <a:prstGeom prst="rect">
+            <a:avLst/>
+          </a:prstGeom>
+          <a:noFill/>
+        </p:spPr>
+        <p:txBody>
+          <a:bodyPr wrap="square" lIns="0" rIns="0" tIns="0" bIns="0" anchor="t">
+            <a:spAutoFit/>
+          </a:bodyPr>
+          <a:lstStyle/>
+          <a:p>
+            <a:pPr algn="l">
+              <a:lnSpc>
+                <a:spcPct val="115000"/>
+              </a:lnSpc>
+            </a:pPr>
+            <a:r>
+              <a:rPr sz="1300" b="1" i="0" spc="200">
+                <a:solidFill>
+                  <a:srgbClr val="1A8FC2"/>
+                </a:solidFill>
+                <a:latin typeface="DM Sans"/>
+              </a:rPr>
+              <a:t>MAIN BRANCH — SUBMISSION</a:t>
+            </a:r>
+          </a:p>
+        </p:txBody>
+      </p:sp>
+      <p:sp>
+        <p:nvSpPr>
+          <p:cNvPr id="23" name="TextBox 22"/>
+          <p:cNvSpPr txBox="1"/>
+          <p:nvPr/>
+        </p:nvSpPr>
+        <p:spPr>
+          <a:xfrm>
+            <a:off x="6413500" y="2349500"/>
+            <a:ext cx="4826000" cy="203200"/>
+          </a:xfrm>
+          <a:prstGeom prst="rect">
+            <a:avLst/>
+          </a:prstGeom>
+          <a:noFill/>
+        </p:spPr>
+        <p:txBody>
+          <a:bodyPr wrap="square" lIns="0" rIns="0" tIns="0" bIns="0" anchor="t">
+            <a:spAutoFit/>
+          </a:bodyPr>
+          <a:lstStyle/>
+          <a:p>
+            <a:pPr algn="l">
+              <a:lnSpc>
+                <a:spcPct val="115000"/>
+              </a:lnSpc>
+            </a:pPr>
+            <a:r>
+              <a:rPr sz="1100" b="1" i="0">
+                <a:solidFill>
+                  <a:srgbClr val="0D1B2A"/>
+                </a:solidFill>
+                <a:latin typeface="DM Sans"/>
+              </a:rPr>
+              <a:t>React 19 SPA</a:t>
+            </a:r>
+          </a:p>
+        </p:txBody>
+      </p:sp>
+      <p:sp>
+        <p:nvSpPr>
+          <p:cNvPr id="24" name="TextBox 23"/>
+          <p:cNvSpPr txBox="1"/>
+          <p:nvPr/>
+        </p:nvSpPr>
+        <p:spPr>
+          <a:xfrm>
+            <a:off x="6413500" y="2565400"/>
+            <a:ext cx="4826000" cy="317500"/>
+          </a:xfrm>
+          <a:prstGeom prst="rect">
+            <a:avLst/>
+          </a:prstGeom>
+          <a:noFill/>
+        </p:spPr>
+        <p:txBody>
+          <a:bodyPr wrap="square" lIns="0" rIns="0" tIns="0" bIns="0" anchor="t">
+            <a:spAutoFit/>
+          </a:bodyPr>
+          <a:lstStyle/>
+          <a:p>
+            <a:pPr algn="l">
+              <a:lnSpc>
+                <a:spcPct val="130000"/>
+              </a:lnSpc>
+            </a:pPr>
+            <a:r>
+              <a:rPr sz="900" b="0" i="0">
+                <a:solidFill>
+                  <a:srgbClr val="5A6A7E"/>
+                </a:solidFill>
+                <a:latin typeface="DM Sans"/>
+              </a:rPr>
+              <a:t>Role-based dashboards for admin / doctor / patient / receptionist.</a:t>
+            </a:r>
+          </a:p>
+        </p:txBody>
+      </p:sp>
+      <p:sp>
+        <p:nvSpPr>
+          <p:cNvPr id="25" name="TextBox 24"/>
+          <p:cNvSpPr txBox="1"/>
+          <p:nvPr/>
+        </p:nvSpPr>
+        <p:spPr>
+          <a:xfrm>
+            <a:off x="6413500" y="2857500"/>
+            <a:ext cx="4826000" cy="203200"/>
+          </a:xfrm>
+          <a:prstGeom prst="rect">
+            <a:avLst/>
+          </a:prstGeom>
+          <a:noFill/>
+        </p:spPr>
+        <p:txBody>
+          <a:bodyPr wrap="square" lIns="0" rIns="0" tIns="0" bIns="0" anchor="t">
+            <a:spAutoFit/>
+          </a:bodyPr>
+          <a:lstStyle/>
+          <a:p>
+            <a:pPr algn="l">
+              <a:lnSpc>
+                <a:spcPct val="115000"/>
+              </a:lnSpc>
+            </a:pPr>
+            <a:r>
+              <a:rPr sz="1100" b="1" i="0">
+                <a:solidFill>
+                  <a:srgbClr val="0D1B2A"/>
+                </a:solidFill>
+                <a:latin typeface="DM Sans"/>
+              </a:rPr>
+              <a:t>HospitalRecords.sol</a:t>
+            </a:r>
+          </a:p>
+        </p:txBody>
+      </p:sp>
+      <p:sp>
+        <p:nvSpPr>
+          <p:cNvPr id="26" name="TextBox 25"/>
+          <p:cNvSpPr txBox="1"/>
+          <p:nvPr/>
+        </p:nvSpPr>
+        <p:spPr>
+          <a:xfrm>
+            <a:off x="6413500" y="3073400"/>
+            <a:ext cx="4826000" cy="317500"/>
+          </a:xfrm>
+          <a:prstGeom prst="rect">
+            <a:avLst/>
+          </a:prstGeom>
+          <a:noFill/>
+        </p:spPr>
+        <p:txBody>
+          <a:bodyPr wrap="square" lIns="0" rIns="0" tIns="0" bIns="0" anchor="t">
+            <a:spAutoFit/>
+          </a:bodyPr>
+          <a:lstStyle/>
+          <a:p>
+            <a:pPr algn="l">
+              <a:lnSpc>
+                <a:spcPct val="130000"/>
+              </a:lnSpc>
+            </a:pPr>
+            <a:r>
+              <a:rPr sz="900" b="0" i="0">
+                <a:solidFill>
+                  <a:srgbClr val="5A6A7E"/>
+                </a:solidFill>
+                <a:latin typeface="DM Sans"/>
+              </a:rPr>
+              <a:t>Solidity 0.8.19 contract — 4 structs, payBillOnChain payable.</a:t>
+            </a:r>
+          </a:p>
+        </p:txBody>
+      </p:sp>
+      <p:sp>
+        <p:nvSpPr>
+          <p:cNvPr id="27" name="TextBox 26"/>
+          <p:cNvSpPr txBox="1"/>
+          <p:nvPr/>
+        </p:nvSpPr>
+        <p:spPr>
+          <a:xfrm>
+            <a:off x="6413500" y="3365500"/>
+            <a:ext cx="4826000" cy="203200"/>
+          </a:xfrm>
+          <a:prstGeom prst="rect">
+            <a:avLst/>
+          </a:prstGeom>
+          <a:noFill/>
+        </p:spPr>
+        <p:txBody>
+          <a:bodyPr wrap="square" lIns="0" rIns="0" tIns="0" bIns="0" anchor="t">
+            <a:spAutoFit/>
+          </a:bodyPr>
+          <a:lstStyle/>
+          <a:p>
+            <a:pPr algn="l">
+              <a:lnSpc>
+                <a:spcPct val="115000"/>
+              </a:lnSpc>
+            </a:pPr>
+            <a:r>
+              <a:rPr sz="1100" b="1" i="0">
+                <a:solidFill>
+                  <a:srgbClr val="0D1B2A"/>
+                </a:solidFill>
+                <a:latin typeface="DM Sans"/>
+              </a:rPr>
+              <a:t>web3.js + Ganache pipeline</a:t>
+            </a:r>
+          </a:p>
+        </p:txBody>
+      </p:sp>
+      <p:sp>
+        <p:nvSpPr>
+          <p:cNvPr id="28" name="TextBox 27"/>
+          <p:cNvSpPr txBox="1"/>
+          <p:nvPr/>
+        </p:nvSpPr>
+        <p:spPr>
+          <a:xfrm>
+            <a:off x="6413500" y="3581400"/>
+            <a:ext cx="4826000" cy="317500"/>
+          </a:xfrm>
+          <a:prstGeom prst="rect">
+            <a:avLst/>
+          </a:prstGeom>
+          <a:noFill/>
+        </p:spPr>
+        <p:txBody>
+          <a:bodyPr wrap="square" lIns="0" rIns="0" tIns="0" bIns="0" anchor="t">
+            <a:spAutoFit/>
+          </a:bodyPr>
+          <a:lstStyle/>
+          <a:p>
+            <a:pPr algn="l">
+              <a:lnSpc>
+                <a:spcPct val="130000"/>
+              </a:lnSpc>
+            </a:pPr>
+            <a:r>
+              <a:rPr sz="900" b="0" i="0">
+                <a:solidFill>
+                  <a:srgbClr val="5A6A7E"/>
+                </a:solidFill>
+                <a:latin typeface="DM Sans"/>
+              </a:rPr>
+              <a:t>Every mutating write mirrored on-chain; tx hash persisted to Mongo.</a:t>
+            </a:r>
+          </a:p>
+        </p:txBody>
+      </p:sp>
+      <p:sp>
+        <p:nvSpPr>
+          <p:cNvPr id="29" name="TextBox 28"/>
+          <p:cNvSpPr txBox="1"/>
+          <p:nvPr/>
+        </p:nvSpPr>
+        <p:spPr>
+          <a:xfrm>
+            <a:off x="6413500" y="3873500"/>
+            <a:ext cx="4826000" cy="203200"/>
+          </a:xfrm>
+          <a:prstGeom prst="rect">
+            <a:avLst/>
+          </a:prstGeom>
+          <a:noFill/>
+        </p:spPr>
+        <p:txBody>
+          <a:bodyPr wrap="square" lIns="0" rIns="0" tIns="0" bIns="0" anchor="t">
+            <a:spAutoFit/>
+          </a:bodyPr>
+          <a:lstStyle/>
+          <a:p>
+            <a:pPr algn="l">
+              <a:lnSpc>
+                <a:spcPct val="115000"/>
+              </a:lnSpc>
+            </a:pPr>
+            <a:r>
+              <a:rPr sz="1100" b="1" i="0">
+                <a:solidFill>
+                  <a:srgbClr val="0D1B2A"/>
+                </a:solidFill>
+                <a:latin typeface="DM Sans"/>
+              </a:rPr>
+              <a:t>MetaMask integration</a:t>
+            </a:r>
+          </a:p>
+        </p:txBody>
+      </p:sp>
+      <p:sp>
+        <p:nvSpPr>
+          <p:cNvPr id="30" name="TextBox 29"/>
+          <p:cNvSpPr txBox="1"/>
+          <p:nvPr/>
+        </p:nvSpPr>
+        <p:spPr>
+          <a:xfrm>
+            <a:off x="6413500" y="4089400"/>
+            <a:ext cx="4826000" cy="317500"/>
+          </a:xfrm>
+          <a:prstGeom prst="rect">
+            <a:avLst/>
+          </a:prstGeom>
+          <a:noFill/>
+        </p:spPr>
+        <p:txBody>
+          <a:bodyPr wrap="square" lIns="0" rIns="0" tIns="0" bIns="0" anchor="t">
+            <a:spAutoFit/>
+          </a:bodyPr>
+          <a:lstStyle/>
+          <a:p>
+            <a:pPr algn="l">
+              <a:lnSpc>
+                <a:spcPct val="130000"/>
+              </a:lnSpc>
+            </a:pPr>
+            <a:r>
+              <a:rPr sz="900" b="0" i="0">
+                <a:solidFill>
+                  <a:srgbClr val="5A6A7E"/>
+                </a:solidFill>
+                <a:latin typeface="DM Sans"/>
+              </a:rPr>
+              <a:t>Fully decentralised patient payments via window.ethereum.</a:t>
+            </a:r>
+          </a:p>
+        </p:txBody>
+      </p:sp>
+      <p:sp>
+        <p:nvSpPr>
+          <p:cNvPr id="31" name="TextBox 30"/>
+          <p:cNvSpPr txBox="1"/>
+          <p:nvPr/>
+        </p:nvSpPr>
+        <p:spPr>
+          <a:xfrm>
+            <a:off x="6413500" y="4381500"/>
+            <a:ext cx="4826000" cy="203200"/>
+          </a:xfrm>
+          <a:prstGeom prst="rect">
+            <a:avLst/>
+          </a:prstGeom>
+          <a:noFill/>
+        </p:spPr>
+        <p:txBody>
+          <a:bodyPr wrap="square" lIns="0" rIns="0" tIns="0" bIns="0" anchor="t">
+            <a:spAutoFit/>
+          </a:bodyPr>
+          <a:lstStyle/>
+          <a:p>
+            <a:pPr algn="l">
+              <a:lnSpc>
+                <a:spcPct val="115000"/>
+              </a:lnSpc>
+            </a:pPr>
+            <a:r>
+              <a:rPr sz="1100" b="1" i="0">
+                <a:solidFill>
+                  <a:srgbClr val="0D1B2A"/>
+                </a:solidFill>
+                <a:latin typeface="DM Sans"/>
+              </a:rPr>
+              <a:t>recharts analytics + jsPDF</a:t>
+            </a:r>
+          </a:p>
+        </p:txBody>
+      </p:sp>
+      <p:sp>
+        <p:nvSpPr>
+          <p:cNvPr id="32" name="TextBox 31"/>
+          <p:cNvSpPr txBox="1"/>
+          <p:nvPr/>
+        </p:nvSpPr>
+        <p:spPr>
+          <a:xfrm>
+            <a:off x="6413500" y="4597400"/>
+            <a:ext cx="4826000" cy="317500"/>
+          </a:xfrm>
+          <a:prstGeom prst="rect">
+            <a:avLst/>
+          </a:prstGeom>
+          <a:noFill/>
+        </p:spPr>
+        <p:txBody>
+          <a:bodyPr wrap="square" lIns="0" rIns="0" tIns="0" bIns="0" anchor="t">
+            <a:spAutoFit/>
+          </a:bodyPr>
+          <a:lstStyle/>
+          <a:p>
+            <a:pPr algn="l">
+              <a:lnSpc>
+                <a:spcPct val="130000"/>
+              </a:lnSpc>
+            </a:pPr>
+            <a:r>
+              <a:rPr sz="900" b="0" i="0">
+                <a:solidFill>
+                  <a:srgbClr val="5A6A7E"/>
+                </a:solidFill>
+                <a:latin typeface="DM Sans"/>
+              </a:rPr>
+              <a:t>Admin charts, revenue trends, exportable bill/rx PDFs.</a:t>
+            </a:r>
+          </a:p>
+        </p:txBody>
+      </p:sp>
+      <p:sp>
+        <p:nvSpPr>
+          <p:cNvPr id="33" name="TextBox 32"/>
+          <p:cNvSpPr txBox="1"/>
+          <p:nvPr/>
+        </p:nvSpPr>
+        <p:spPr>
+          <a:xfrm>
+            <a:off x="6413500" y="4889500"/>
+            <a:ext cx="4826000" cy="203200"/>
+          </a:xfrm>
+          <a:prstGeom prst="rect">
+            <a:avLst/>
+          </a:prstGeom>
+          <a:noFill/>
+        </p:spPr>
+        <p:txBody>
+          <a:bodyPr wrap="square" lIns="0" rIns="0" tIns="0" bIns="0" anchor="t">
+            <a:spAutoFit/>
+          </a:bodyPr>
+          <a:lstStyle/>
+          <a:p>
+            <a:pPr algn="l">
+              <a:lnSpc>
+                <a:spcPct val="115000"/>
+              </a:lnSpc>
+            </a:pPr>
+            <a:r>
+              <a:rPr sz="1100" b="1" i="0">
+                <a:solidFill>
+                  <a:srgbClr val="0D1B2A"/>
+                </a:solidFill>
+                <a:latin typeface="DM Sans"/>
+              </a:rPr>
+              <a:t>Audit log, notifications, tests</a:t>
+            </a:r>
+          </a:p>
+        </p:txBody>
+      </p:sp>
+      <p:sp>
+        <p:nvSpPr>
+          <p:cNvPr id="34" name="TextBox 33"/>
+          <p:cNvSpPr txBox="1"/>
+          <p:nvPr/>
+        </p:nvSpPr>
+        <p:spPr>
+          <a:xfrm>
+            <a:off x="6413500" y="5105400"/>
+            <a:ext cx="4826000" cy="317500"/>
+          </a:xfrm>
+          <a:prstGeom prst="rect">
+            <a:avLst/>
+          </a:prstGeom>
+          <a:noFill/>
+        </p:spPr>
+        <p:txBody>
+          <a:bodyPr wrap="square" lIns="0" rIns="0" tIns="0" bIns="0" anchor="t">
+            <a:spAutoFit/>
+          </a:bodyPr>
+          <a:lstStyle/>
+          <a:p>
+            <a:pPr algn="l">
+              <a:lnSpc>
+                <a:spcPct val="130000"/>
+              </a:lnSpc>
+            </a:pPr>
+            <a:r>
+              <a:rPr sz="900" b="0" i="0">
+                <a:solidFill>
+                  <a:srgbClr val="5A6A7E"/>
+                </a:solidFill>
+                <a:latin typeface="DM Sans"/>
+              </a:rPr>
+              <a:t>Mutation middleware, bell polling, Jest suites, RBAC fixes.</a:t>
+            </a:r>
+          </a:p>
+        </p:txBody>
+      </p:sp>
+      <p:sp>
+        <p:nvSpPr>
+          <p:cNvPr id="35" name="Rounded Rectangle 34"/>
+          <p:cNvSpPr/>
+          <p:nvPr/>
+        </p:nvSpPr>
+        <p:spPr>
+          <a:xfrm>
+            <a:off x="762000" y="5588000"/>
+            <a:ext cx="10667969" cy="571500"/>
+          </a:xfrm>
+          <a:prstGeom prst="roundRect">
+            <a:avLst>
+              <a:gd name="adj" fmla="val 4000"/>
+            </a:avLst>
+          </a:prstGeom>
+          <a:solidFill>
+            <a:srgbClr val="F2F5FA"/>
+          </a:solidFill>
+          <a:ln>
+            <a:noFill/>
+          </a:ln>
+          <a:effectLst/>
+        </p:spPr>
+        <p:style>
+          <a:lnRef idx="1">
+            <a:schemeClr val="accent1"/>
+          </a:lnRef>
+          <a:fillRef idx="3">
+            <a:schemeClr val="accent1"/>
+          </a:fillRef>
+          <a:effectRef idx="2">
+            <a:schemeClr val="accent1"/>
+          </a:effectRef>
+          <a:fontRef idx="minor">
+            <a:schemeClr val="lt1"/>
+          </a:fontRef>
+        </p:style>
+        <p:txBody>
+          <a:bodyPr rtlCol="0" anchor="ctr"/>
+          <a:lstStyle/>
+          <a:p>
+            <a:pPr algn="ctr"/>
+          </a:p>
+        </p:txBody>
+      </p:sp>
+      <p:sp>
+        <p:nvSpPr>
+          <p:cNvPr id="36" name="TextBox 35"/>
+          <p:cNvSpPr txBox="1"/>
+          <p:nvPr/>
+        </p:nvSpPr>
+        <p:spPr>
+          <a:xfrm>
+            <a:off x="889000" y="5664200"/>
+            <a:ext cx="10413969" cy="177800"/>
+          </a:xfrm>
+          <a:prstGeom prst="rect">
+            <a:avLst/>
+          </a:prstGeom>
+          <a:noFill/>
+        </p:spPr>
+        <p:txBody>
+          <a:bodyPr wrap="square" lIns="0" rIns="0" tIns="0" bIns="0" anchor="t">
+            <a:spAutoFit/>
+          </a:bodyPr>
+          <a:lstStyle/>
+          <a:p>
+            <a:pPr algn="l">
+              <a:lnSpc>
+                <a:spcPct val="115000"/>
+              </a:lnSpc>
+            </a:pPr>
+            <a:r>
+              <a:rPr sz="900" b="1" i="0" spc="200">
+                <a:solidFill>
+                  <a:srgbClr val="1A8FC2"/>
+                </a:solidFill>
+                <a:latin typeface="DM Sans"/>
+              </a:rPr>
+              <a:t>REPO LINKS</a:t>
+            </a:r>
+          </a:p>
+        </p:txBody>
+      </p:sp>
+      <p:sp>
+        <p:nvSpPr>
+          <p:cNvPr id="37" name="TextBox 36"/>
+          <p:cNvSpPr txBox="1"/>
+          <p:nvPr/>
+        </p:nvSpPr>
+        <p:spPr>
+          <a:xfrm>
+            <a:off x="889000" y="5842000"/>
+            <a:ext cx="10413969" cy="279400"/>
+          </a:xfrm>
+          <a:prstGeom prst="rect">
+            <a:avLst/>
+          </a:prstGeom>
+          <a:noFill/>
+        </p:spPr>
+        <p:txBody>
+          <a:bodyPr wrap="square" lIns="0" rIns="0" tIns="0" bIns="0" anchor="t">
+            <a:spAutoFit/>
+          </a:bodyPr>
+          <a:lstStyle/>
+          <a:p>
+            <a:pPr algn="l">
+              <a:lnSpc>
+                <a:spcPct val="140000"/>
+              </a:lnSpc>
+            </a:pPr>
+            <a:r>
+              <a:rPr sz="800" b="0" i="0">
+                <a:solidFill>
+                  <a:srgbClr val="0D1B2A"/>
                 </a:solidFill>
                 <a:latin typeface="DM Mono"/>
               </a:rPr>
-              <a:t>[ Insert MS Stream link here ]</a:t>
-            </a:r>
-          </a:p>
-        </p:txBody>
-      </p:sp>
-      <p:sp>
-        <p:nvSpPr>
-          <p:cNvPr id="8" name="TextBox 7"/>
-          <p:cNvSpPr txBox="1"/>
-          <p:nvPr/>
-        </p:nvSpPr>
-        <p:spPr>
-          <a:xfrm>
-            <a:off x="1270000" y="5143500"/>
-            <a:ext cx="9651969" cy="825500"/>
-          </a:xfrm>
-          <a:prstGeom prst="rect">
-            <a:avLst/>
-          </a:prstGeom>
-          <a:noFill/>
-        </p:spPr>
-        <p:txBody>
-          <a:bodyPr wrap="square" lIns="0" rIns="0" tIns="0" bIns="0" anchor="t">
-            <a:spAutoFit/>
-          </a:bodyPr>
-          <a:lstStyle/>
-          <a:p>
-            <a:pPr algn="ctr">
-              <a:lnSpc>
-                <a:spcPct val="160000"/>
-              </a:lnSpc>
-            </a:pPr>
-            <a:r>
-              <a:rPr sz="1200" b="0" i="0">
-                <a:solidFill>
-                  <a:srgbClr val="8A94A2"/>
-                </a:solidFill>
-                <a:latin typeface="DM Sans"/>
-              </a:rPr>
-              <a:t>Access has been granted to all lab tutors.</a:t>
-            </a:r>
-          </a:p>
-          <a:p>
-            <a:pPr algn="ctr">
-              <a:lnSpc>
-                <a:spcPct val="160000"/>
-              </a:lnSpc>
-            </a:pPr>
-            <a:r>
-              <a:rPr sz="1200" b="0" i="0">
-                <a:solidFill>
-                  <a:srgbClr val="8A94A2"/>
-                </a:solidFill>
-                <a:latin typeface="DM Sans"/>
-              </a:rPr>
-              <a:t>The recording covers login as each role · appointment booking · on-chain transaction logging · MetaMask bill payment · blockchain verification.</a:t>
+              <a:t>Submission (main):  github.com/rahmane001/hospital-system/tree/main</a:t>
+            </a:r>
+          </a:p>
+          <a:p>
+            <a:pPr algn="l">
+              <a:lnSpc>
+                <a:spcPct val="140000"/>
+              </a:lnSpc>
+            </a:pPr>
+            <a:r>
+              <a:rPr sz="800" b="0" i="0">
+                <a:solidFill>
+                  <a:srgbClr val="0D1B2A"/>
+                </a:solidFill>
+                <a:latin typeface="DM Mono"/>
+              </a:rPr>
+              <a:t>Baseline (master): github.com/rahmane001/hospital-system/tree/master   ·   Diff: github.com/rahmane001/hospital-system/compare/master...main</a:t>
             </a:r>
           </a:p>
         </p:txBody>
@@ -7645,6 +8872,327 @@
             <a:avLst/>
           </a:prstGeom>
           <a:solidFill>
+            <a:srgbClr val="0D1B2A"/>
+          </a:solidFill>
+          <a:ln>
+            <a:noFill/>
+          </a:ln>
+          <a:effectLst/>
+        </p:spPr>
+        <p:style>
+          <a:lnRef idx="1">
+            <a:schemeClr val="accent1"/>
+          </a:lnRef>
+          <a:fillRef idx="3">
+            <a:schemeClr val="accent1"/>
+          </a:fillRef>
+          <a:effectRef idx="2">
+            <a:schemeClr val="accent1"/>
+          </a:effectRef>
+          <a:fontRef idx="minor">
+            <a:schemeClr val="lt1"/>
+          </a:fontRef>
+        </p:style>
+        <p:txBody>
+          <a:bodyPr rtlCol="0" anchor="ctr"/>
+          <a:lstStyle/>
+          <a:p>
+            <a:pPr algn="ctr"/>
+          </a:p>
+        </p:txBody>
+      </p:sp>
+      <p:sp>
+        <p:nvSpPr>
+          <p:cNvPr id="3" name="TextBox 2"/>
+          <p:cNvSpPr txBox="1"/>
+          <p:nvPr/>
+        </p:nvSpPr>
+        <p:spPr>
+          <a:xfrm>
+            <a:off x="0" y="1651000"/>
+            <a:ext cx="12191969" cy="215900"/>
+          </a:xfrm>
+          <a:prstGeom prst="rect">
+            <a:avLst/>
+          </a:prstGeom>
+          <a:noFill/>
+        </p:spPr>
+        <p:txBody>
+          <a:bodyPr wrap="square" lIns="0" rIns="0" tIns="0" bIns="0" anchor="t">
+            <a:spAutoFit/>
+          </a:bodyPr>
+          <a:lstStyle/>
+          <a:p>
+            <a:pPr algn="ctr">
+              <a:lnSpc>
+                <a:spcPct val="115000"/>
+              </a:lnSpc>
+            </a:pPr>
+            <a:r>
+              <a:rPr sz="1200" b="1" i="0" spc="240">
+                <a:solidFill>
+                  <a:srgbClr val="6CB8DA"/>
+                </a:solidFill>
+                <a:latin typeface="DM Sans"/>
+              </a:rPr>
+              <a:t>12 — DEMONSTRATION</a:t>
+            </a:r>
+          </a:p>
+        </p:txBody>
+      </p:sp>
+      <p:sp>
+        <p:nvSpPr>
+          <p:cNvPr id="4" name="TextBox 3"/>
+          <p:cNvSpPr txBox="1"/>
+          <p:nvPr/>
+        </p:nvSpPr>
+        <p:spPr>
+          <a:xfrm>
+            <a:off x="0" y="2095500"/>
+            <a:ext cx="12191969" cy="762000"/>
+          </a:xfrm>
+          <a:prstGeom prst="rect">
+            <a:avLst/>
+          </a:prstGeom>
+          <a:noFill/>
+        </p:spPr>
+        <p:txBody>
+          <a:bodyPr wrap="square" lIns="0" rIns="0" tIns="0" bIns="0" anchor="t">
+            <a:spAutoFit/>
+          </a:bodyPr>
+          <a:lstStyle/>
+          <a:p>
+            <a:pPr algn="ctr">
+              <a:lnSpc>
+                <a:spcPct val="115000"/>
+              </a:lnSpc>
+            </a:pPr>
+            <a:r>
+              <a:rPr sz="4000" b="1" i="0">
+                <a:solidFill>
+                  <a:srgbClr val="F9FAFB"/>
+                </a:solidFill>
+                <a:latin typeface="DM Sans"/>
+              </a:rPr>
+              <a:t>Video Demonstration</a:t>
+            </a:r>
+          </a:p>
+        </p:txBody>
+      </p:sp>
+      <p:sp>
+        <p:nvSpPr>
+          <p:cNvPr id="5" name="Rounded Rectangle 4"/>
+          <p:cNvSpPr/>
+          <p:nvPr/>
+        </p:nvSpPr>
+        <p:spPr>
+          <a:xfrm>
+            <a:off x="2285984" y="3365500"/>
+            <a:ext cx="7620000" cy="1397000"/>
+          </a:xfrm>
+          <a:prstGeom prst="roundRect">
+            <a:avLst>
+              <a:gd name="adj" fmla="val 8000"/>
+            </a:avLst>
+          </a:prstGeom>
+          <a:solidFill>
+            <a:srgbClr val="182A42"/>
+          </a:solidFill>
+          <a:ln w="25400">
+            <a:solidFill>
+              <a:srgbClr val="244A70"/>
+            </a:solidFill>
+          </a:ln>
+          <a:effectLst/>
+        </p:spPr>
+        <p:style>
+          <a:lnRef idx="1">
+            <a:schemeClr val="accent1"/>
+          </a:lnRef>
+          <a:fillRef idx="3">
+            <a:schemeClr val="accent1"/>
+          </a:fillRef>
+          <a:effectRef idx="2">
+            <a:schemeClr val="accent1"/>
+          </a:effectRef>
+          <a:fontRef idx="minor">
+            <a:schemeClr val="lt1"/>
+          </a:fontRef>
+        </p:style>
+        <p:txBody>
+          <a:bodyPr rtlCol="0" anchor="ctr"/>
+          <a:lstStyle/>
+          <a:p>
+            <a:pPr algn="ctr"/>
+          </a:p>
+        </p:txBody>
+      </p:sp>
+      <p:sp>
+        <p:nvSpPr>
+          <p:cNvPr id="6" name="TextBox 5"/>
+          <p:cNvSpPr txBox="1"/>
+          <p:nvPr/>
+        </p:nvSpPr>
+        <p:spPr>
+          <a:xfrm>
+            <a:off x="2285984" y="3619500"/>
+            <a:ext cx="7620000" cy="228600"/>
+          </a:xfrm>
+          <a:prstGeom prst="rect">
+            <a:avLst/>
+          </a:prstGeom>
+          <a:noFill/>
+        </p:spPr>
+        <p:txBody>
+          <a:bodyPr wrap="square" lIns="0" rIns="0" tIns="0" bIns="0" anchor="t">
+            <a:spAutoFit/>
+          </a:bodyPr>
+          <a:lstStyle/>
+          <a:p>
+            <a:pPr algn="ctr">
+              <a:lnSpc>
+                <a:spcPct val="115000"/>
+              </a:lnSpc>
+            </a:pPr>
+            <a:r>
+              <a:rPr sz="1200" b="1" i="0" spc="200">
+                <a:solidFill>
+                  <a:srgbClr val="8A94A2"/>
+                </a:solidFill>
+                <a:latin typeface="DM Sans"/>
+              </a:rPr>
+              <a:t>MS STREAM RECORDING</a:t>
+            </a:r>
+          </a:p>
+        </p:txBody>
+      </p:sp>
+      <p:sp>
+        <p:nvSpPr>
+          <p:cNvPr id="7" name="TextBox 6"/>
+          <p:cNvSpPr txBox="1"/>
+          <p:nvPr/>
+        </p:nvSpPr>
+        <p:spPr>
+          <a:xfrm>
+            <a:off x="2539984" y="4000500"/>
+            <a:ext cx="7112000" cy="508000"/>
+          </a:xfrm>
+          <a:prstGeom prst="rect">
+            <a:avLst/>
+          </a:prstGeom>
+          <a:noFill/>
+        </p:spPr>
+        <p:txBody>
+          <a:bodyPr wrap="square" lIns="0" rIns="0" tIns="0" bIns="0" anchor="t">
+            <a:spAutoFit/>
+          </a:bodyPr>
+          <a:lstStyle/>
+          <a:p>
+            <a:pPr algn="ctr">
+              <a:lnSpc>
+                <a:spcPct val="115000"/>
+              </a:lnSpc>
+            </a:pPr>
+            <a:r>
+              <a:rPr sz="1600" b="0" i="0">
+                <a:solidFill>
+                  <a:srgbClr val="6CB8DA"/>
+                </a:solidFill>
+                <a:latin typeface="DM Mono"/>
+              </a:rPr>
+              <a:t>[ Insert MS Stream link here ]</a:t>
+            </a:r>
+          </a:p>
+        </p:txBody>
+      </p:sp>
+      <p:sp>
+        <p:nvSpPr>
+          <p:cNvPr id="8" name="TextBox 7"/>
+          <p:cNvSpPr txBox="1"/>
+          <p:nvPr/>
+        </p:nvSpPr>
+        <p:spPr>
+          <a:xfrm>
+            <a:off x="1270000" y="5143500"/>
+            <a:ext cx="9651969" cy="825500"/>
+          </a:xfrm>
+          <a:prstGeom prst="rect">
+            <a:avLst/>
+          </a:prstGeom>
+          <a:noFill/>
+        </p:spPr>
+        <p:txBody>
+          <a:bodyPr wrap="square" lIns="0" rIns="0" tIns="0" bIns="0" anchor="t">
+            <a:spAutoFit/>
+          </a:bodyPr>
+          <a:lstStyle/>
+          <a:p>
+            <a:pPr algn="ctr">
+              <a:lnSpc>
+                <a:spcPct val="160000"/>
+              </a:lnSpc>
+            </a:pPr>
+            <a:r>
+              <a:rPr sz="1200" b="0" i="0">
+                <a:solidFill>
+                  <a:srgbClr val="8A94A2"/>
+                </a:solidFill>
+                <a:latin typeface="DM Sans"/>
+              </a:rPr>
+              <a:t>Access has been granted to all lab tutors.</a:t>
+            </a:r>
+          </a:p>
+          <a:p>
+            <a:pPr algn="ctr">
+              <a:lnSpc>
+                <a:spcPct val="160000"/>
+              </a:lnSpc>
+            </a:pPr>
+            <a:r>
+              <a:rPr sz="1200" b="0" i="0">
+                <a:solidFill>
+                  <a:srgbClr val="8A94A2"/>
+                </a:solidFill>
+                <a:latin typeface="DM Sans"/>
+              </a:rPr>
+              <a:t>The recording covers login as each role · appointment booking · on-chain transaction logging · MetaMask bill payment · blockchain verification.</a:t>
+            </a:r>
+          </a:p>
+        </p:txBody>
+      </p:sp>
+    </p:spTree>
+  </p:cSld>
+  <p:clrMapOvr>
+    <a:masterClrMapping/>
+  </p:clrMapOvr>
+</p:sld>
+</file>
+
+<file path=ppt/slides/slide14.xml><?xml version="1.0" encoding="utf-8"?>
+<p:sld xmlns:a="http://schemas.openxmlformats.org/drawingml/2006/main" xmlns:p="http://schemas.openxmlformats.org/presentationml/2006/main" xmlns:r="http://schemas.openxmlformats.org/officeDocument/2006/relationships">
+  <p:cSld>
+    <p:spTree>
+      <p:nvGrpSpPr>
+        <p:cNvPr id="1" name=""/>
+        <p:cNvGrpSpPr/>
+        <p:nvPr/>
+      </p:nvGrpSpPr>
+      <p:grpSpPr/>
+      <p:sp>
+        <p:nvSpPr>
+          <p:cNvPr id="2" name="Rectangle 1"/>
+          <p:cNvSpPr/>
+          <p:nvPr/>
+        </p:nvSpPr>
+        <p:spPr>
+          <a:xfrm>
+            <a:off x="0" y="0"/>
+            <a:ext cx="12191969" cy="6858000"/>
+          </a:xfrm>
+          <a:prstGeom prst="rect">
+            <a:avLst/>
+          </a:prstGeom>
+          <a:solidFill>
             <a:srgbClr val="F9FAFB"/>
           </a:solidFill>
           <a:ln>
@@ -7708,7 +9256,7 @@
                 </a:solidFill>
                 <a:latin typeface="DM Sans"/>
               </a:rPr>
-              <a:t>12 — REFERENCES</a:t>
+              <a:t>13 — REFERENCES</a:t>
             </a:r>
           </a:p>
         </p:txBody>

</xml_diff>